<commit_message>
add 50 oop chapter
</commit_message>
<xml_diff>
--- a/26fall/1860/Lecture/Week1.5/Lab 1.5.1 HDL & CAD Intro LAB 1.pptx
+++ b/26fall/1860/Lecture/Week1.5/Lab 1.5.1 HDL & CAD Intro LAB 1.pptx
@@ -15977,12 +15977,6 @@
             <a:endParaRPr lang="en-US" altLang="zh-CN" sz="1600" dirty="0"/>
           </a:p>
           <a:p>
-            <a:pPr marL="742950" indent="-514350">
-              <a:buAutoNum type="arabicPeriod"/>
-            </a:pPr>
-            <a:endParaRPr lang="en-US" altLang="zh-CN" sz="1600" dirty="0"/>
-          </a:p>
-          <a:p>
             <a:pPr marL="571500" indent="-342900">
               <a:buAutoNum type="arabicPeriod" startAt="3"/>
             </a:pPr>
@@ -16259,6 +16253,397 @@
           </a:prstGeom>
         </p:spPr>
       </p:pic>
+      <p:graphicFrame>
+        <p:nvGraphicFramePr>
+          <p:cNvPr id="5" name="Content Placeholder 9">
+            <a:extLst>
+              <a:ext uri="{FF2B5EF4-FFF2-40B4-BE49-F238E27FC236}">
+                <a16:creationId xmlns:a16="http://schemas.microsoft.com/office/drawing/2014/main" id="{FD2B2DD6-43B3-1FB8-FD5D-886C264880DB}"/>
+              </a:ext>
+            </a:extLst>
+          </p:cNvPr>
+          <p:cNvGraphicFramePr>
+            <a:graphicFrameLocks/>
+          </p:cNvGraphicFramePr>
+          <p:nvPr>
+            <p:extLst>
+              <p:ext uri="{D42A27DB-BD31-4B8C-83A1-F6EECF244321}">
+                <p14:modId xmlns:p14="http://schemas.microsoft.com/office/powerpoint/2010/main" val="451400504"/>
+              </p:ext>
+            </p:extLst>
+          </p:nvPr>
+        </p:nvGraphicFramePr>
+        <p:xfrm>
+          <a:off x="795839" y="4252431"/>
+          <a:ext cx="3609885" cy="822960"/>
+        </p:xfrm>
+        <a:graphic>
+          <a:graphicData uri="http://schemas.openxmlformats.org/drawingml/2006/table">
+            <a:tbl>
+              <a:tblPr firstRow="1" bandRow="1">
+                <a:tableStyleId>{7E9639D4-E3E2-4D34-9284-5A2195B3D0D7}</a:tableStyleId>
+              </a:tblPr>
+              <a:tblGrid>
+                <a:gridCol w="721977">
+                  <a:extLst>
+                    <a:ext uri="{9D8B030D-6E8A-4147-A177-3AD203B41FA5}">
+                      <a16:colId xmlns:a16="http://schemas.microsoft.com/office/drawing/2014/main" val="248199293"/>
+                    </a:ext>
+                  </a:extLst>
+                </a:gridCol>
+                <a:gridCol w="721977">
+                  <a:extLst>
+                    <a:ext uri="{9D8B030D-6E8A-4147-A177-3AD203B41FA5}">
+                      <a16:colId xmlns:a16="http://schemas.microsoft.com/office/drawing/2014/main" val="1031720830"/>
+                    </a:ext>
+                  </a:extLst>
+                </a:gridCol>
+                <a:gridCol w="721977">
+                  <a:extLst>
+                    <a:ext uri="{9D8B030D-6E8A-4147-A177-3AD203B41FA5}">
+                      <a16:colId xmlns:a16="http://schemas.microsoft.com/office/drawing/2014/main" val="2150626135"/>
+                    </a:ext>
+                  </a:extLst>
+                </a:gridCol>
+                <a:gridCol w="721977">
+                  <a:extLst>
+                    <a:ext uri="{9D8B030D-6E8A-4147-A177-3AD203B41FA5}">
+                      <a16:colId xmlns:a16="http://schemas.microsoft.com/office/drawing/2014/main" val="3304944525"/>
+                    </a:ext>
+                  </a:extLst>
+                </a:gridCol>
+                <a:gridCol w="721977">
+                  <a:extLst>
+                    <a:ext uri="{9D8B030D-6E8A-4147-A177-3AD203B41FA5}">
+                      <a16:colId xmlns:a16="http://schemas.microsoft.com/office/drawing/2014/main" val="3896279477"/>
+                    </a:ext>
+                  </a:extLst>
+                </a:gridCol>
+              </a:tblGrid>
+              <a:tr h="254951">
+                <a:tc>
+                  <a:txBody>
+                    <a:bodyPr/>
+                    <a:lstStyle/>
+                    <a:p>
+                      <a:r>
+                        <a:rPr lang="en-GB" sz="1200" dirty="0"/>
+                        <a:t>A  BC</a:t>
+                      </a:r>
+                    </a:p>
+                  </a:txBody>
+                  <a:tcPr>
+                    <a:lnTlToBr w="28575" cap="flat" cmpd="sng" algn="ctr">
+                      <a:solidFill>
+                        <a:schemeClr val="bg1"/>
+                      </a:solidFill>
+                      <a:prstDash val="solid"/>
+                      <a:round/>
+                      <a:headEnd type="none" w="med" len="med"/>
+                      <a:tailEnd type="none" w="med" len="med"/>
+                    </a:lnTlToBr>
+                  </a:tcPr>
+                </a:tc>
+                <a:tc>
+                  <a:txBody>
+                    <a:bodyPr/>
+                    <a:lstStyle/>
+                    <a:p>
+                      <a:r>
+                        <a:rPr lang="en-GB" sz="1200" dirty="0"/>
+                        <a:t>00</a:t>
+                      </a:r>
+                    </a:p>
+                  </a:txBody>
+                  <a:tcPr/>
+                </a:tc>
+                <a:tc>
+                  <a:txBody>
+                    <a:bodyPr/>
+                    <a:lstStyle/>
+                    <a:p>
+                      <a:r>
+                        <a:rPr lang="en-GB" sz="1200" dirty="0"/>
+                        <a:t>01</a:t>
+                      </a:r>
+                    </a:p>
+                  </a:txBody>
+                  <a:tcPr/>
+                </a:tc>
+                <a:tc>
+                  <a:txBody>
+                    <a:bodyPr/>
+                    <a:lstStyle/>
+                    <a:p>
+                      <a:r>
+                        <a:rPr lang="en-GB" sz="1200" dirty="0"/>
+                        <a:t>11</a:t>
+                      </a:r>
+                    </a:p>
+                  </a:txBody>
+                  <a:tcPr/>
+                </a:tc>
+                <a:tc>
+                  <a:txBody>
+                    <a:bodyPr/>
+                    <a:lstStyle/>
+                    <a:p>
+                      <a:r>
+                        <a:rPr lang="en-GB" sz="1200" dirty="0"/>
+                        <a:t>10</a:t>
+                      </a:r>
+                    </a:p>
+                  </a:txBody>
+                  <a:tcPr/>
+                </a:tc>
+                <a:extLst>
+                  <a:ext uri="{0D108BD9-81ED-4DB2-BD59-A6C34878D82A}">
+                    <a16:rowId xmlns:a16="http://schemas.microsoft.com/office/drawing/2014/main" val="1511229784"/>
+                  </a:ext>
+                </a:extLst>
+              </a:tr>
+              <a:tr h="213767">
+                <a:tc>
+                  <a:txBody>
+                    <a:bodyPr/>
+                    <a:lstStyle/>
+                    <a:p>
+                      <a:r>
+                        <a:rPr lang="en-GB" sz="1200" b="1" dirty="0">
+                          <a:solidFill>
+                            <a:schemeClr val="bg1"/>
+                          </a:solidFill>
+                        </a:rPr>
+                        <a:t>0</a:t>
+                      </a:r>
+                    </a:p>
+                  </a:txBody>
+                  <a:tcPr>
+                    <a:lnB w="12700" cap="flat" cmpd="sng" algn="ctr">
+                      <a:noFill/>
+                      <a:prstDash val="solid"/>
+                      <a:round/>
+                      <a:headEnd type="none" w="med" len="med"/>
+                      <a:tailEnd type="none" w="med" len="med"/>
+                    </a:lnB>
+                    <a:solidFill>
+                      <a:schemeClr val="tx1"/>
+                    </a:solidFill>
+                  </a:tcPr>
+                </a:tc>
+                <a:tc>
+                  <a:txBody>
+                    <a:bodyPr/>
+                    <a:lstStyle/>
+                    <a:p>
+                      <a:r>
+                        <a:rPr lang="en-GB" sz="1200" dirty="0"/>
+                        <a:t>0</a:t>
+                      </a:r>
+                    </a:p>
+                  </a:txBody>
+                  <a:tcPr>
+                    <a:lnB w="12700" cap="flat" cmpd="sng" algn="ctr">
+                      <a:noFill/>
+                      <a:prstDash val="solid"/>
+                      <a:round/>
+                      <a:headEnd type="none" w="med" len="med"/>
+                      <a:tailEnd type="none" w="med" len="med"/>
+                    </a:lnB>
+                  </a:tcPr>
+                </a:tc>
+                <a:tc>
+                  <a:txBody>
+                    <a:bodyPr/>
+                    <a:lstStyle/>
+                    <a:p>
+                      <a:r>
+                        <a:rPr lang="en-GB" sz="1200" dirty="0"/>
+                        <a:t>0</a:t>
+                      </a:r>
+                    </a:p>
+                  </a:txBody>
+                  <a:tcPr>
+                    <a:lnB w="12700" cap="flat" cmpd="sng" algn="ctr">
+                      <a:noFill/>
+                      <a:prstDash val="solid"/>
+                      <a:round/>
+                      <a:headEnd type="none" w="med" len="med"/>
+                      <a:tailEnd type="none" w="med" len="med"/>
+                    </a:lnB>
+                  </a:tcPr>
+                </a:tc>
+                <a:tc>
+                  <a:txBody>
+                    <a:bodyPr/>
+                    <a:lstStyle/>
+                    <a:p>
+                      <a:r>
+                        <a:rPr lang="en-GB" sz="1200" dirty="0"/>
+                        <a:t>1</a:t>
+                      </a:r>
+                    </a:p>
+                  </a:txBody>
+                  <a:tcPr>
+                    <a:lnB w="12700" cap="flat" cmpd="sng" algn="ctr">
+                      <a:noFill/>
+                      <a:prstDash val="solid"/>
+                      <a:round/>
+                      <a:headEnd type="none" w="med" len="med"/>
+                      <a:tailEnd type="none" w="med" len="med"/>
+                    </a:lnB>
+                  </a:tcPr>
+                </a:tc>
+                <a:tc>
+                  <a:txBody>
+                    <a:bodyPr/>
+                    <a:lstStyle/>
+                    <a:p>
+                      <a:r>
+                        <a:rPr lang="en-GB" sz="1200" dirty="0"/>
+                        <a:t>1</a:t>
+                      </a:r>
+                    </a:p>
+                  </a:txBody>
+                  <a:tcPr>
+                    <a:lnB w="12700" cap="flat" cmpd="sng" algn="ctr">
+                      <a:noFill/>
+                      <a:prstDash val="solid"/>
+                      <a:round/>
+                      <a:headEnd type="none" w="med" len="med"/>
+                      <a:tailEnd type="none" w="med" len="med"/>
+                    </a:lnB>
+                  </a:tcPr>
+                </a:tc>
+                <a:extLst>
+                  <a:ext uri="{0D108BD9-81ED-4DB2-BD59-A6C34878D82A}">
+                    <a16:rowId xmlns:a16="http://schemas.microsoft.com/office/drawing/2014/main" val="3459221812"/>
+                  </a:ext>
+                </a:extLst>
+              </a:tr>
+              <a:tr h="213767">
+                <a:tc>
+                  <a:txBody>
+                    <a:bodyPr/>
+                    <a:lstStyle/>
+                    <a:p>
+                      <a:r>
+                        <a:rPr lang="en-GB" sz="1200" b="1" dirty="0">
+                          <a:solidFill>
+                            <a:schemeClr val="bg1"/>
+                          </a:solidFill>
+                        </a:rPr>
+                        <a:t>1</a:t>
+                      </a:r>
+                    </a:p>
+                  </a:txBody>
+                  <a:tcPr>
+                    <a:lnT w="12700" cap="flat" cmpd="sng" algn="ctr">
+                      <a:noFill/>
+                      <a:prstDash val="solid"/>
+                      <a:round/>
+                      <a:headEnd type="none" w="med" len="med"/>
+                      <a:tailEnd type="none" w="med" len="med"/>
+                    </a:lnT>
+                    <a:solidFill>
+                      <a:schemeClr val="tx1"/>
+                    </a:solidFill>
+                  </a:tcPr>
+                </a:tc>
+                <a:tc>
+                  <a:txBody>
+                    <a:bodyPr/>
+                    <a:lstStyle/>
+                    <a:p>
+                      <a:r>
+                        <a:rPr lang="en-GB" sz="1200" dirty="0"/>
+                        <a:t>0</a:t>
+                      </a:r>
+                    </a:p>
+                  </a:txBody>
+                  <a:tcPr>
+                    <a:lnT w="12700" cap="flat" cmpd="sng" algn="ctr">
+                      <a:noFill/>
+                      <a:prstDash val="solid"/>
+                      <a:round/>
+                      <a:headEnd type="none" w="med" len="med"/>
+                      <a:tailEnd type="none" w="med" len="med"/>
+                    </a:lnT>
+                  </a:tcPr>
+                </a:tc>
+                <a:tc>
+                  <a:txBody>
+                    <a:bodyPr/>
+                    <a:lstStyle/>
+                    <a:p>
+                      <a:r>
+                        <a:rPr lang="en-GB" sz="1200" dirty="0"/>
+                        <a:t>0</a:t>
+                      </a:r>
+                    </a:p>
+                  </a:txBody>
+                  <a:tcPr>
+                    <a:lnT w="12700" cap="flat" cmpd="sng" algn="ctr">
+                      <a:noFill/>
+                      <a:prstDash val="solid"/>
+                      <a:round/>
+                      <a:headEnd type="none" w="med" len="med"/>
+                      <a:tailEnd type="none" w="med" len="med"/>
+                    </a:lnT>
+                  </a:tcPr>
+                </a:tc>
+                <a:tc>
+                  <a:txBody>
+                    <a:bodyPr/>
+                    <a:lstStyle/>
+                    <a:p>
+                      <a:r>
+                        <a:rPr lang="en-GB" sz="1200" dirty="0"/>
+                        <a:t>0</a:t>
+                      </a:r>
+                    </a:p>
+                  </a:txBody>
+                  <a:tcPr>
+                    <a:lnT w="12700" cap="flat" cmpd="sng" algn="ctr">
+                      <a:noFill/>
+                      <a:prstDash val="solid"/>
+                      <a:round/>
+                      <a:headEnd type="none" w="med" len="med"/>
+                      <a:tailEnd type="none" w="med" len="med"/>
+                    </a:lnT>
+                  </a:tcPr>
+                </a:tc>
+                <a:tc>
+                  <a:txBody>
+                    <a:bodyPr/>
+                    <a:lstStyle/>
+                    <a:p>
+                      <a:r>
+                        <a:rPr lang="en-GB" sz="1200" dirty="0"/>
+                        <a:t>1</a:t>
+                      </a:r>
+                    </a:p>
+                  </a:txBody>
+                  <a:tcPr>
+                    <a:lnT w="12700" cap="flat" cmpd="sng" algn="ctr">
+                      <a:noFill/>
+                      <a:prstDash val="solid"/>
+                      <a:round/>
+                      <a:headEnd type="none" w="med" len="med"/>
+                      <a:tailEnd type="none" w="med" len="med"/>
+                    </a:lnT>
+                  </a:tcPr>
+                </a:tc>
+                <a:extLst>
+                  <a:ext uri="{0D108BD9-81ED-4DB2-BD59-A6C34878D82A}">
+                    <a16:rowId xmlns:a16="http://schemas.microsoft.com/office/drawing/2014/main" val="2538775327"/>
+                  </a:ext>
+                </a:extLst>
+              </a:tr>
+            </a:tbl>
+          </a:graphicData>
+        </a:graphic>
+      </p:graphicFrame>
     </p:spTree>
     <p:extLst>
       <p:ext uri="{BB962C8B-B14F-4D97-AF65-F5344CB8AC3E}">

</xml_diff>